<commit_message>
feature: atualiza stack das trajetorias de 2025 e 2026
</commit_message>
<xml_diff>
--- a/public/img-home/apresentacoes/rhyan-lemos-apresentacao.pptx
+++ b/public/img-home/apresentacoes/rhyan-lemos-apresentacao.pptx
@@ -9776,24 +9776,27 @@
         </p:nvSpPr>
         <p:spPr>
           <a:xfrm>
-            <a:off x="723882" y="4838579"/>
-            <a:ext cx="1866853" cy="190495"/>
-          </a:xfrm>
-          <a:prstGeom prst="rect">
-            <a:avLst/>
-          </a:prstGeom>
-          <a:noFill/>
-          <a:ln/>
-        </p:spPr>
-        <p:txBody>
-          <a:bodyPr wrap="square" lIns="0" tIns="0" rIns="0" bIns="0" rtlCol="0" anchor="t"/>
-          <a:lstStyle/>
-          <a:p>
-            <a:pPr indent="0" marL="0">
-              <a:buNone/>
-            </a:pPr>
-            <a:r>
-              <a:rPr lang="en-US" sz="525" dirty="0">
+            <a:off x="723882" y="4724282"/>
+            <a:ext cx="1866853" cy="380990"/>
+          </a:xfrm>
+          <a:prstGeom prst="rect">
+            <a:avLst/>
+          </a:prstGeom>
+          <a:noFill/>
+          <a:ln/>
+        </p:spPr>
+        <p:txBody>
+          <a:bodyPr wrap="square" lIns="0" tIns="0" rIns="0" bIns="0" rtlCol="0" anchor="b"/>
+          <a:lstStyle/>
+          <a:p>
+            <a:pPr indent="0" marL="0">
+              <a:lnSpc>
+                <a:spcPts val="600"/>
+              </a:lnSpc>
+              <a:buNone/>
+            </a:pPr>
+            <a:r>
+              <a:rPr lang="en-US" sz="488" dirty="0">
                 <a:solidFill>
                   <a:srgbClr val="93A6B8"/>
                 </a:solidFill>
@@ -9801,9 +9804,9 @@
                 <a:ea typeface="Segoe UI" pitchFamily="34" charset="-122"/>
                 <a:cs typeface="Segoe UI" pitchFamily="34" charset="-120"/>
               </a:rPr>
-              <a:t>Redes  ·  Suporte  ·  HTML  ·  CSS</a:t>
-            </a:r>
-            <a:endParaRPr lang="en-US" sz="525" dirty="0"/>
+              <a:t>Redes · Suporte · HTML · CSS · Git</a:t>
+            </a:r>
+            <a:endParaRPr lang="en-US" sz="488" dirty="0"/>
           </a:p>
         </p:txBody>
       </p:sp>
@@ -10122,24 +10125,27 @@
         </p:nvSpPr>
         <p:spPr>
           <a:xfrm>
-            <a:off x="2895528" y="4838579"/>
-            <a:ext cx="1866853" cy="190495"/>
-          </a:xfrm>
-          <a:prstGeom prst="rect">
-            <a:avLst/>
-          </a:prstGeom>
-          <a:noFill/>
-          <a:ln/>
-        </p:spPr>
-        <p:txBody>
-          <a:bodyPr wrap="square" lIns="0" tIns="0" rIns="0" bIns="0" rtlCol="0" anchor="t"/>
-          <a:lstStyle/>
-          <a:p>
-            <a:pPr indent="0" marL="0">
-              <a:buNone/>
-            </a:pPr>
-            <a:r>
-              <a:rPr lang="en-US" sz="525" dirty="0">
+            <a:off x="2895528" y="4724282"/>
+            <a:ext cx="1866853" cy="380990"/>
+          </a:xfrm>
+          <a:prstGeom prst="rect">
+            <a:avLst/>
+          </a:prstGeom>
+          <a:noFill/>
+          <a:ln/>
+        </p:spPr>
+        <p:txBody>
+          <a:bodyPr wrap="square" lIns="0" tIns="0" rIns="0" bIns="0" rtlCol="0" anchor="b"/>
+          <a:lstStyle/>
+          <a:p>
+            <a:pPr indent="0" marL="0">
+              <a:lnSpc>
+                <a:spcPts val="600"/>
+              </a:lnSpc>
+              <a:buNone/>
+            </a:pPr>
+            <a:r>
+              <a:rPr lang="en-US" sz="488" dirty="0">
                 <a:solidFill>
                   <a:srgbClr val="93A6B8"/>
                 </a:solidFill>
@@ -10147,9 +10153,9 @@
                 <a:ea typeface="Segoe UI" pitchFamily="34" charset="-122"/>
                 <a:cs typeface="Segoe UI" pitchFamily="34" charset="-120"/>
               </a:rPr>
-              <a:t>PHP  ·  Node.js  ·  MySQL  ·  MVC</a:t>
-            </a:r>
-            <a:endParaRPr lang="en-US" sz="525" dirty="0"/>
+              <a:t>PHP · Node.js · MySQL · MVC</a:t>
+            </a:r>
+            <a:endParaRPr lang="en-US" sz="488" dirty="0"/>
           </a:p>
         </p:txBody>
       </p:sp>
@@ -10468,24 +10474,27 @@
         </p:nvSpPr>
         <p:spPr>
           <a:xfrm>
-            <a:off x="5067173" y="4838579"/>
-            <a:ext cx="1866853" cy="190495"/>
-          </a:xfrm>
-          <a:prstGeom prst="rect">
-            <a:avLst/>
-          </a:prstGeom>
-          <a:noFill/>
-          <a:ln/>
-        </p:spPr>
-        <p:txBody>
-          <a:bodyPr wrap="square" lIns="0" tIns="0" rIns="0" bIns="0" rtlCol="0" anchor="t"/>
-          <a:lstStyle/>
-          <a:p>
-            <a:pPr indent="0" marL="0">
-              <a:buNone/>
-            </a:pPr>
-            <a:r>
-              <a:rPr lang="en-US" sz="525" dirty="0">
+            <a:off x="5067173" y="4724282"/>
+            <a:ext cx="1866853" cy="380990"/>
+          </a:xfrm>
+          <a:prstGeom prst="rect">
+            <a:avLst/>
+          </a:prstGeom>
+          <a:noFill/>
+          <a:ln/>
+        </p:spPr>
+        <p:txBody>
+          <a:bodyPr wrap="square" lIns="0" tIns="0" rIns="0" bIns="0" rtlCol="0" anchor="b"/>
+          <a:lstStyle/>
+          <a:p>
+            <a:pPr indent="0" marL="0">
+              <a:lnSpc>
+                <a:spcPts val="600"/>
+              </a:lnSpc>
+              <a:buNone/>
+            </a:pPr>
+            <a:r>
+              <a:rPr lang="en-US" sz="488" dirty="0">
                 <a:solidFill>
                   <a:srgbClr val="93A6B8"/>
                 </a:solidFill>
@@ -10493,9 +10502,9 @@
                 <a:ea typeface="Segoe UI" pitchFamily="34" charset="-122"/>
                 <a:cs typeface="Segoe UI" pitchFamily="34" charset="-120"/>
               </a:rPr>
-              <a:t>IA  ·  WhatsApp  ·  Prototipação  ·  GitHub</a:t>
-            </a:r>
-            <a:endParaRPr lang="en-US" sz="525" dirty="0"/>
+              <a:t>IA · WhatsApp · Prototipação · GitHub</a:t>
+            </a:r>
+            <a:endParaRPr lang="en-US" sz="488" dirty="0"/>
           </a:p>
         </p:txBody>
       </p:sp>
@@ -10814,24 +10823,27 @@
         </p:nvSpPr>
         <p:spPr>
           <a:xfrm>
-            <a:off x="7238819" y="4838579"/>
-            <a:ext cx="1866853" cy="190495"/>
-          </a:xfrm>
-          <a:prstGeom prst="rect">
-            <a:avLst/>
-          </a:prstGeom>
-          <a:noFill/>
-          <a:ln/>
-        </p:spPr>
-        <p:txBody>
-          <a:bodyPr wrap="square" lIns="0" tIns="0" rIns="0" bIns="0" rtlCol="0" anchor="t"/>
-          <a:lstStyle/>
-          <a:p>
-            <a:pPr indent="0" marL="0">
-              <a:buNone/>
-            </a:pPr>
-            <a:r>
-              <a:rPr lang="en-US" sz="525" dirty="0">
+            <a:off x="7238819" y="4724282"/>
+            <a:ext cx="1866853" cy="380990"/>
+          </a:xfrm>
+          <a:prstGeom prst="rect">
+            <a:avLst/>
+          </a:prstGeom>
+          <a:noFill/>
+          <a:ln/>
+        </p:spPr>
+        <p:txBody>
+          <a:bodyPr wrap="square" lIns="0" tIns="0" rIns="0" bIns="0" rtlCol="0" anchor="b"/>
+          <a:lstStyle/>
+          <a:p>
+            <a:pPr indent="0" marL="0">
+              <a:lnSpc>
+                <a:spcPts val="600"/>
+              </a:lnSpc>
+              <a:buNone/>
+            </a:pPr>
+            <a:r>
+              <a:rPr lang="en-US" sz="488" dirty="0">
                 <a:solidFill>
                   <a:srgbClr val="93A6B8"/>
                 </a:solidFill>
@@ -10839,9 +10851,9 @@
                 <a:ea typeface="Segoe UI" pitchFamily="34" charset="-122"/>
                 <a:cs typeface="Segoe UI" pitchFamily="34" charset="-120"/>
               </a:rPr>
-              <a:t>Full Stack  ·  PHP  ·  TypeScript  ·  CI/CD</a:t>
-            </a:r>
-            <a:endParaRPr lang="en-US" sz="525" dirty="0"/>
+              <a:t>Python · TypeScript · JavaScript · Docker · Docker Compose · Tailwind CSS · HTML · Figma · QA</a:t>
+            </a:r>
+            <a:endParaRPr lang="en-US" sz="488" dirty="0"/>
           </a:p>
         </p:txBody>
       </p:sp>
@@ -11216,7 +11228,7 @@
                 <a:ea typeface="Segoe UI" pitchFamily="34" charset="-122"/>
                 <a:cs typeface="Segoe UI" pitchFamily="34" charset="-120"/>
               </a:rPr>
-              <a:t>▸ Projetos com React, PHP e automação</a:t>
+              <a:t>▸ Projetos com React, TypeScript e automação</a:t>
             </a:r>
             <a:endParaRPr lang="en-US" sz="600" dirty="0"/>
           </a:p>
@@ -11230,24 +11242,27 @@
         </p:nvSpPr>
         <p:spPr>
           <a:xfrm>
-            <a:off x="9410465" y="4838579"/>
-            <a:ext cx="1866853" cy="190495"/>
-          </a:xfrm>
-          <a:prstGeom prst="rect">
-            <a:avLst/>
-          </a:prstGeom>
-          <a:noFill/>
-          <a:ln/>
-        </p:spPr>
-        <p:txBody>
-          <a:bodyPr wrap="square" lIns="0" tIns="0" rIns="0" bIns="0" rtlCol="0" anchor="t"/>
-          <a:lstStyle/>
-          <a:p>
-            <a:pPr indent="0" marL="0">
-              <a:buNone/>
-            </a:pPr>
-            <a:r>
-              <a:rPr lang="en-US" sz="525" dirty="0">
+            <a:off x="9410465" y="4724282"/>
+            <a:ext cx="1866853" cy="380990"/>
+          </a:xfrm>
+          <a:prstGeom prst="rect">
+            <a:avLst/>
+          </a:prstGeom>
+          <a:noFill/>
+          <a:ln/>
+        </p:spPr>
+        <p:txBody>
+          <a:bodyPr wrap="square" lIns="0" tIns="0" rIns="0" bIns="0" rtlCol="0" anchor="b"/>
+          <a:lstStyle/>
+          <a:p>
+            <a:pPr indent="0" marL="0">
+              <a:lnSpc>
+                <a:spcPts val="600"/>
+              </a:lnSpc>
+              <a:buNone/>
+            </a:pPr>
+            <a:r>
+              <a:rPr lang="en-US" sz="488" dirty="0">
                 <a:solidFill>
                   <a:srgbClr val="93A6B8"/>
                 </a:solidFill>
@@ -11255,9 +11270,9 @@
                 <a:ea typeface="Segoe UI" pitchFamily="34" charset="-122"/>
                 <a:cs typeface="Segoe UI" pitchFamily="34" charset="-120"/>
               </a:rPr>
-              <a:t>Azure  ·  CI/CD  ·  Liderança  ·  Arquitetura</a:t>
-            </a:r>
-            <a:endParaRPr lang="en-US" sz="525" dirty="0"/>
+              <a:t>Azure · CI/CD · Kubernetes · Estudos de IA · Arquitetura · Liderança · Mentoria · QA · Figma · Coleta e maturação de feedback</a:t>
+            </a:r>
+            <a:endParaRPr lang="en-US" sz="488" dirty="0"/>
           </a:p>
         </p:txBody>
       </p:sp>

</xml_diff>